<commit_message>
Presentation: merge evaluator + source-of-truth into one slide
Slides 15 & 16 merged into a single slide showing the evaluator agent DEPENDS on
the user-provided source-of-truth (reference) answer; renumber later slides.
</commit_message>
<xml_diff>
--- a/Legal_AI_Academic_Presentation.pptx
+++ b/Legal_AI_Academic_Presentation.pptx
@@ -30,7 +30,6 @@
     <p:sldId id="278" r:id="rId29"/>
     <p:sldId id="279" r:id="rId30"/>
     <p:sldId id="280" r:id="rId31"/>
-    <p:sldId id="281" r:id="rId32"/>
   </p:sldIdLst>
   <p:sldSz cx="12191695" cy="6858000" type="screen4x3"/>
   <p:notesSz cx="6858000" cy="9144000"/>
@@ -5599,7 +5598,7 @@
                   <a:srgbClr val="FFFFFF"/>
                 </a:solidFill>
               </a:rPr>
-              <a:t>15. The Evaluator Agent (LLM-as-Judge)</a:t>
+              <a:t>15. The Evaluator Agent — Judging Against the Source of Truth</a:t>
             </a:r>
           </a:p>
           <a:p>
@@ -5609,7 +5608,7 @@
                   <a:srgbClr val="BFD3E6"/>
                 </a:solidFill>
               </a:rPr>
-              <a:t>A separate LLM scores each answer — an automated expert reviewer</a:t>
+              <a:t>An independent LLM judge scores each answer relative to the user's ground-truth answer</a:t>
             </a:r>
           </a:p>
         </p:txBody>
@@ -5638,7 +5637,7 @@
           <a:p>
             <a:pPr>
               <a:spcAft>
-                <a:spcPts val="800"/>
+                <a:spcPts val="900"/>
               </a:spcAft>
             </a:pPr>
             <a:r>
@@ -5655,13 +5654,13 @@
                   <a:srgbClr val="444444"/>
                 </a:solidFill>
               </a:rPr>
-              <a:t>a second, independent LLM (Claude), separate from the answering agents.</a:t>
-            </a:r>
-          </a:p>
-          <a:p>
-            <a:pPr>
-              <a:spcAft>
-                <a:spcPts val="800"/>
+              <a:t>a second, independent LLM (Claude, temperature 0), separate from the answering agents.</a:t>
+            </a:r>
+          </a:p>
+          <a:p>
+            <a:pPr>
+              <a:spcAft>
+                <a:spcPts val="900"/>
               </a:spcAft>
             </a:pPr>
             <a:r>
@@ -5670,7 +5669,7 @@
                   <a:srgbClr val="1E3A5F"/>
                 </a:solidFill>
               </a:rPr>
-              <a:t>• Deterministic: </a:t>
+              <a:t>• Depends on the reference: </a:t>
             </a:r>
             <a:r>
               <a:rPr sz="1500" b="0" i="0">
@@ -5678,13 +5677,13 @@
                   <a:srgbClr val="444444"/>
                 </a:solidFill>
               </a:rPr>
-              <a:t>temperature 0 for consistent, deterministic scoring.</a:t>
-            </a:r>
-          </a:p>
-          <a:p>
-            <a:pPr>
-              <a:spcAft>
-                <a:spcPts val="800"/>
+              <a:t>the user provides the correct expert answer per question — the SOURCE OF TRUTH.</a:t>
+            </a:r>
+          </a:p>
+          <a:p>
+            <a:pPr>
+              <a:spcAft>
+                <a:spcPts val="900"/>
               </a:spcAft>
             </a:pPr>
             <a:r>
@@ -5693,6 +5692,29 @@
                   <a:srgbClr val="1E3A5F"/>
                 </a:solidFill>
               </a:rPr>
+              <a:t>• How it scores: </a:t>
+            </a:r>
+            <a:r>
+              <a:rPr sz="1500" b="0" i="0">
+                <a:solidFill>
+                  <a:srgbClr val="444444"/>
+                </a:solidFill>
+              </a:rPr>
+              <a:t>the judge compares the AI answer AGAINST that reference — it does NOT score on its own opinion.</a:t>
+            </a:r>
+          </a:p>
+          <a:p>
+            <a:pPr>
+              <a:spcAft>
+                <a:spcPts val="900"/>
+              </a:spcAft>
+            </a:pPr>
+            <a:r>
+              <a:rPr sz="1500" b="1" i="0">
+                <a:solidFill>
+                  <a:srgbClr val="1E3A5F"/>
+                </a:solidFill>
+              </a:rPr>
               <a:t>• Rubric: </a:t>
             </a:r>
             <a:r>
@@ -5701,13 +5723,13 @@
                   <a:srgbClr val="444444"/>
                 </a:solidFill>
               </a:rPr>
-              <a:t>scores 4 dimensions 1–5: legal correctness, citation quality, completeness, clarity.</a:t>
-            </a:r>
-          </a:p>
-          <a:p>
-            <a:pPr>
-              <a:spcAft>
-                <a:spcPts val="800"/>
+              <a:t>4 dimensions 1–5 (legal correctness, citation quality, completeness, clarity), judged vs. the reference.</a:t>
+            </a:r>
+          </a:p>
+          <a:p>
+            <a:pPr>
+              <a:spcAft>
+                <a:spcPts val="900"/>
               </a:spcAft>
             </a:pPr>
             <a:r>
@@ -5716,7 +5738,7 @@
                   <a:srgbClr val="1E3A5F"/>
                 </a:solidFill>
               </a:rPr>
-              <a:t>• Output: </a:t>
+              <a:t>• Why it matters: </a:t>
             </a:r>
             <a:r>
               <a:rPr sz="1500" b="0" i="0">
@@ -5724,30 +5746,7 @@
                   <a:srgbClr val="444444"/>
                 </a:solidFill>
               </a:rPr>
-              <a:t>returns a strict JSON verdict + a one-line explanation; the average is the score.</a:t>
-            </a:r>
-          </a:p>
-          <a:p>
-            <a:pPr>
-              <a:spcAft>
-                <a:spcPts val="800"/>
-              </a:spcAft>
-            </a:pPr>
-            <a:r>
-              <a:rPr sz="1500" b="1" i="0">
-                <a:solidFill>
-                  <a:srgbClr val="1E3A5F"/>
-                </a:solidFill>
-              </a:rPr>
-              <a:t>• Cross-checked: </a:t>
-            </a:r>
-            <a:r>
-              <a:rPr sz="1500" b="0" i="0">
-                <a:solidFill>
-                  <a:srgbClr val="444444"/>
-                </a:solidFill>
-              </a:rPr>
-              <a:t>objective citation-F1 (vs gold articles) is ALSO computed automatically to cross-check the judge.</a:t>
+              <a:t>grounds evaluation in human expertise → objective &amp; reproducible; REQUIRED for a judged run.</a:t>
             </a:r>
           </a:p>
         </p:txBody>
@@ -5760,8 +5759,8 @@
         </p:nvSpPr>
         <p:spPr>
           <a:xfrm>
-            <a:off x="6858000" y="1371600"/>
-            <a:ext cx="4800600" cy="4206240"/>
+            <a:off x="6858000" y="1280160"/>
+            <a:ext cx="4800600" cy="4389120"/>
           </a:xfrm>
           <a:prstGeom prst="rect">
             <a:avLst/>
@@ -5800,7 +5799,7 @@
                 </a:solidFill>
                 <a:latin typeface="Consolas"/>
               </a:rPr>
-              <a:t>Judge prompt (reference-free)</a:t>
+              <a:t>Judge prompt (reference-based)</a:t>
             </a:r>
           </a:p>
           <a:p>
@@ -5832,7 +5831,7 @@
                 </a:solidFill>
                 <a:latin typeface="Consolas"/>
               </a:rPr>
-              <a:t>User Query: "..."</a:t>
+              <a:t>Compare the AI answer against the</a:t>
             </a:r>
           </a:p>
           <a:p>
@@ -5848,7 +5847,7 @@
                 </a:solidFill>
                 <a:latin typeface="Consolas"/>
               </a:rPr>
-              <a:t>Legal Memorandum: "..."</a:t>
+              <a:t>REFERENCE (ground-truth) answer.</a:t>
             </a:r>
           </a:p>
           <a:p>
@@ -5880,7 +5879,7 @@
                 </a:solidFill>
                 <a:latin typeface="Consolas"/>
               </a:rPr>
-              <a:t>Score each 1-5:</a:t>
+              <a:t>REFERENCE answer: "..."  (from the user)</a:t>
             </a:r>
           </a:p>
           <a:p>
@@ -5896,6 +5895,54 @@
                 </a:solidFill>
                 <a:latin typeface="Consolas"/>
               </a:rPr>
+              <a:t>AI answer: "..."</a:t>
+            </a:r>
+          </a:p>
+          <a:p>
+            <a:pPr>
+              <a:spcAft>
+                <a:spcPts val="200"/>
+              </a:spcAft>
+            </a:pPr>
+            <a:r>
+              <a:rPr sz="1100" b="0" i="0">
+                <a:solidFill>
+                  <a:srgbClr val="D7E3F4"/>
+                </a:solidFill>
+                <a:latin typeface="Consolas"/>
+              </a:rPr>
+              <a:t/>
+            </a:r>
+          </a:p>
+          <a:p>
+            <a:pPr>
+              <a:spcAft>
+                <a:spcPts val="200"/>
+              </a:spcAft>
+            </a:pPr>
+            <a:r>
+              <a:rPr sz="1100" b="0" i="0">
+                <a:solidFill>
+                  <a:srgbClr val="D7E3F4"/>
+                </a:solidFill>
+                <a:latin typeface="Consolas"/>
+              </a:rPr>
+              <a:t>Score 1-5, judged AGAINST the reference:</a:t>
+            </a:r>
+          </a:p>
+          <a:p>
+            <a:pPr>
+              <a:spcAft>
+                <a:spcPts val="200"/>
+              </a:spcAft>
+            </a:pPr>
+            <a:r>
+              <a:rPr sz="1100" b="0" i="0">
+                <a:solidFill>
+                  <a:srgbClr val="D7E3F4"/>
+                </a:solidFill>
+                <a:latin typeface="Consolas"/>
+              </a:rPr>
               <a:t>  legal_correctness, citation_quality,</a:t>
             </a:r>
           </a:p>
@@ -5928,39 +5975,7 @@
                 </a:solidFill>
                 <a:latin typeface="Consolas"/>
               </a:rPr>
-              <a:t>Return ONLY JSON:</a:t>
-            </a:r>
-          </a:p>
-          <a:p>
-            <a:pPr>
-              <a:spcAft>
-                <a:spcPts val="200"/>
-              </a:spcAft>
-            </a:pPr>
-            <a:r>
-              <a:rPr sz="1100" b="0" i="0">
-                <a:solidFill>
-                  <a:srgbClr val="D7E3F4"/>
-                </a:solidFill>
-                <a:latin typeface="Consolas"/>
-              </a:rPr>
-              <a:t>  {legal_correctness:N, ... ,</a:t>
-            </a:r>
-          </a:p>
-          <a:p>
-            <a:pPr>
-              <a:spcAft>
-                <a:spcPts val="200"/>
-              </a:spcAft>
-            </a:pPr>
-            <a:r>
-              <a:rPr sz="1100" b="0" i="0">
-                <a:solidFill>
-                  <a:srgbClr val="D7E3F4"/>
-                </a:solidFill>
-                <a:latin typeface="Consolas"/>
-              </a:rPr>
-              <a:t>   explanation:"one sentence"}</a:t>
+              <a:t>Return ONLY JSON.</a:t>
             </a:r>
           </a:p>
         </p:txBody>
@@ -6055,17 +6070,7 @@
                   <a:srgbClr val="FFFFFF"/>
                 </a:solidFill>
               </a:rPr>
-              <a:t>16. The Source-of-Truth (Reference) Answer</a:t>
-            </a:r>
-          </a:p>
-          <a:p>
-            <a:r>
-              <a:rPr sz="1300" b="0" i="0">
-                <a:solidFill>
-                  <a:srgbClr val="BFD3E6"/>
-                </a:solidFill>
-              </a:rPr>
-              <a:t>Why the human ground-truth answer is essential</a:t>
+              <a:t>16. Benchmark — The Workflow in the App</a:t>
             </a:r>
           </a:p>
         </p:txBody>
@@ -6078,8 +6083,8 @@
         </p:nvSpPr>
         <p:spPr>
           <a:xfrm>
-            <a:off x="548640" y="1143000"/>
-            <a:ext cx="6126480" cy="5394960"/>
+            <a:off x="640080" y="1188720"/>
+            <a:ext cx="10911535" cy="5349240"/>
           </a:xfrm>
           <a:prstGeom prst="rect">
             <a:avLst/>
@@ -6098,20 +6103,20 @@
               </a:spcAft>
             </a:pPr>
             <a:r>
-              <a:rPr sz="1500" b="1" i="0">
+              <a:rPr sz="1650" b="1" i="0">
                 <a:solidFill>
                   <a:srgbClr val="1E3A5F"/>
                 </a:solidFill>
               </a:rPr>
-              <a:t>• The problem: </a:t>
-            </a:r>
-            <a:r>
-              <a:rPr sz="1500" b="0" i="0">
+              <a:t>• 1 · Generate: </a:t>
+            </a:r>
+            <a:r>
+              <a:rPr sz="1650" b="0" i="0">
                 <a:solidFill>
                   <a:srgbClr val="444444"/>
                 </a:solidFill>
               </a:rPr>
-              <a:t>without a reference, the judge scores on its own opinion — which can be biased or wrong on Lebanese law.</a:t>
+              <a:t>set the number of questions; the generator produces grounded questions, shown 10 per page.</a:t>
             </a:r>
           </a:p>
           <a:p>
@@ -6121,20 +6126,20 @@
               </a:spcAft>
             </a:pPr>
             <a:r>
-              <a:rPr sz="1500" b="1" i="0">
+              <a:rPr sz="1650" b="1" i="0">
                 <a:solidFill>
                   <a:srgbClr val="1E3A5F"/>
                 </a:solidFill>
               </a:rPr>
-              <a:t>• The fix: </a:t>
-            </a:r>
-            <a:r>
-              <a:rPr sz="1500" b="0" i="0">
+              <a:t>• 2 · Reference: </a:t>
+            </a:r>
+            <a:r>
+              <a:rPr sz="1650" b="0" i="0">
                 <a:solidFill>
                   <a:srgbClr val="444444"/>
                 </a:solidFill>
               </a:rPr>
-              <a:t>the user enters the correct expert answer per question — the SOURCE OF TRUTH.</a:t>
+              <a:t>review them, then type the source-of-truth answer in the editable table (required).</a:t>
             </a:r>
           </a:p>
           <a:p>
@@ -6144,20 +6149,20 @@
               </a:spcAft>
             </a:pPr>
             <a:r>
-              <a:rPr sz="1500" b="1" i="0">
+              <a:rPr sz="1650" b="1" i="0">
                 <a:solidFill>
                   <a:srgbClr val="1E3A5F"/>
                 </a:solidFill>
               </a:rPr>
-              <a:t>• Comparison: </a:t>
-            </a:r>
-            <a:r>
-              <a:rPr sz="1500" b="0" i="0">
+              <a:t>• 3 · Select: </a:t>
+            </a:r>
+            <a:r>
+              <a:rPr sz="1650" b="0" i="0">
                 <a:solidFill>
                   <a:srgbClr val="444444"/>
                 </a:solidFill>
               </a:rPr>
-              <a:t>the judge then compares the AI answer AGAINST this reference (agreement on law, citations, completeness).</a:t>
+              <a:t>choose systems — Multi-Agent vs Single-Agent vs No-RAG.</a:t>
             </a:r>
           </a:p>
           <a:p>
@@ -6167,20 +6172,20 @@
               </a:spcAft>
             </a:pPr>
             <a:r>
-              <a:rPr sz="1500" b="1" i="0">
+              <a:rPr sz="1650" b="1" i="0">
                 <a:solidFill>
                   <a:srgbClr val="1E3A5F"/>
                 </a:solidFill>
               </a:rPr>
-              <a:t>• Why it matters: </a:t>
-            </a:r>
-            <a:r>
-              <a:rPr sz="1500" b="0" i="0">
+              <a:t>• 4 · Run: </a:t>
+            </a:r>
+            <a:r>
+              <a:rPr sz="1650" b="0" i="0">
                 <a:solidFill>
                   <a:srgbClr val="444444"/>
                 </a:solidFill>
               </a:rPr>
-              <a:t>grounds evaluation in human expertise — objective and reproducible, not the judge's guess.</a:t>
+              <a:t>each system answers; the judge scores every answer against the reference.</a:t>
             </a:r>
           </a:p>
           <a:p>
@@ -6190,217 +6195,20 @@
               </a:spcAft>
             </a:pPr>
             <a:r>
-              <a:rPr sz="1500" b="1" i="0">
+              <a:rPr sz="1650" b="1" i="0">
                 <a:solidFill>
                   <a:srgbClr val="1E3A5F"/>
                 </a:solidFill>
               </a:rPr>
-              <a:t>• Mandatory: </a:t>
-            </a:r>
-            <a:r>
-              <a:rPr sz="1500" b="0" i="0">
+              <a:t>• 5 · Results: </a:t>
+            </a:r>
+            <a:r>
+              <a:rPr sz="1650" b="0" i="0">
                 <a:solidFill>
                   <a:srgbClr val="444444"/>
                 </a:solidFill>
               </a:rPr>
-              <a:t>it is REQUIRED for a judged comparison run — the run is blocked until every question has one.</a:t>
-            </a:r>
-          </a:p>
-        </p:txBody>
-      </p:sp>
-      <p:sp>
-        <p:nvSpPr>
-          <p:cNvPr id="5" name="Rectangle 4"/>
-          <p:cNvSpPr/>
-          <p:nvPr/>
-        </p:nvSpPr>
-        <p:spPr>
-          <a:xfrm>
-            <a:off x="6858000" y="1371600"/>
-            <a:ext cx="4800600" cy="3931920"/>
-          </a:xfrm>
-          <a:prstGeom prst="rect">
-            <a:avLst/>
-          </a:prstGeom>
-          <a:solidFill>
-            <a:srgbClr val="0F172A"/>
-          </a:solidFill>
-          <a:ln>
-            <a:noFill/>
-          </a:ln>
-          <a:effectLst/>
-        </p:spPr>
-        <p:style>
-          <a:lnRef idx="1">
-            <a:schemeClr val="accent1"/>
-          </a:lnRef>
-          <a:fillRef idx="3">
-            <a:schemeClr val="accent1"/>
-          </a:fillRef>
-          <a:effectRef idx="2">
-            <a:schemeClr val="accent1"/>
-          </a:effectRef>
-          <a:fontRef idx="minor">
-            <a:schemeClr val="lt1"/>
-          </a:fontRef>
-        </p:style>
-        <p:txBody>
-          <a:bodyPr rtlCol="0" anchor="ctr" wrap="square" lIns="164592" tIns="109728" rIns="137160"/>
-          <a:lstStyle/>
-          <a:p>
-            <a:pPr algn="ctr"/>
-            <a:r>
-              <a:rPr sz="1200" b="1" i="0">
-                <a:solidFill>
-                  <a:srgbClr val="7AD1A0"/>
-                </a:solidFill>
-                <a:latin typeface="Consolas"/>
-              </a:rPr>
-              <a:t>Judge prompt (reference-based)</a:t>
-            </a:r>
-          </a:p>
-          <a:p>
-            <a:pPr>
-              <a:spcAft>
-                <a:spcPts val="200"/>
-              </a:spcAft>
-            </a:pPr>
-            <a:r>
-              <a:rPr sz="1100" b="0" i="0">
-                <a:solidFill>
-                  <a:srgbClr val="D7E3F4"/>
-                </a:solidFill>
-                <a:latin typeface="Consolas"/>
-              </a:rPr>
-              <a:t>Compare the AI answer against the</a:t>
-            </a:r>
-          </a:p>
-          <a:p>
-            <a:pPr>
-              <a:spcAft>
-                <a:spcPts val="200"/>
-              </a:spcAft>
-            </a:pPr>
-            <a:r>
-              <a:rPr sz="1100" b="0" i="0">
-                <a:solidFill>
-                  <a:srgbClr val="D7E3F4"/>
-                </a:solidFill>
-                <a:latin typeface="Consolas"/>
-              </a:rPr>
-              <a:t>REFERENCE (ground-truth) answer.</a:t>
-            </a:r>
-          </a:p>
-          <a:p>
-            <a:pPr>
-              <a:spcAft>
-                <a:spcPts val="200"/>
-              </a:spcAft>
-            </a:pPr>
-            <a:r>
-              <a:rPr sz="1100" b="0" i="0">
-                <a:solidFill>
-                  <a:srgbClr val="D7E3F4"/>
-                </a:solidFill>
-                <a:latin typeface="Consolas"/>
-              </a:rPr>
-              <a:t/>
-            </a:r>
-          </a:p>
-          <a:p>
-            <a:pPr>
-              <a:spcAft>
-                <a:spcPts val="200"/>
-              </a:spcAft>
-            </a:pPr>
-            <a:r>
-              <a:rPr sz="1100" b="0" i="0">
-                <a:solidFill>
-                  <a:srgbClr val="D7E3F4"/>
-                </a:solidFill>
-                <a:latin typeface="Consolas"/>
-              </a:rPr>
-              <a:t>REFERENCE answer: "..."</a:t>
-            </a:r>
-          </a:p>
-          <a:p>
-            <a:pPr>
-              <a:spcAft>
-                <a:spcPts val="200"/>
-              </a:spcAft>
-            </a:pPr>
-            <a:r>
-              <a:rPr sz="1100" b="0" i="0">
-                <a:solidFill>
-                  <a:srgbClr val="D7E3F4"/>
-                </a:solidFill>
-                <a:latin typeface="Consolas"/>
-              </a:rPr>
-              <a:t>AI answer: "..."</a:t>
-            </a:r>
-          </a:p>
-          <a:p>
-            <a:pPr>
-              <a:spcAft>
-                <a:spcPts val="200"/>
-              </a:spcAft>
-            </a:pPr>
-            <a:r>
-              <a:rPr sz="1100" b="0" i="0">
-                <a:solidFill>
-                  <a:srgbClr val="D7E3F4"/>
-                </a:solidFill>
-                <a:latin typeface="Consolas"/>
-              </a:rPr>
-              <a:t/>
-            </a:r>
-          </a:p>
-          <a:p>
-            <a:pPr>
-              <a:spcAft>
-                <a:spcPts val="200"/>
-              </a:spcAft>
-            </a:pPr>
-            <a:r>
-              <a:rPr sz="1100" b="0" i="0">
-                <a:solidFill>
-                  <a:srgbClr val="D7E3F4"/>
-                </a:solidFill>
-                <a:latin typeface="Consolas"/>
-              </a:rPr>
-              <a:t>Score 1-5, judged AGAINST the reference:</a:t>
-            </a:r>
-          </a:p>
-          <a:p>
-            <a:pPr>
-              <a:spcAft>
-                <a:spcPts val="200"/>
-              </a:spcAft>
-            </a:pPr>
-            <a:r>
-              <a:rPr sz="1100" b="0" i="0">
-                <a:solidFill>
-                  <a:srgbClr val="D7E3F4"/>
-                </a:solidFill>
-                <a:latin typeface="Consolas"/>
-              </a:rPr>
-              <a:t>  correctness, citations, completeness,</a:t>
-            </a:r>
-          </a:p>
-          <a:p>
-            <a:pPr>
-              <a:spcAft>
-                <a:spcPts val="200"/>
-              </a:spcAft>
-            </a:pPr>
-            <a:r>
-              <a:rPr sz="1100" b="0" i="0">
-                <a:solidFill>
-                  <a:srgbClr val="D7E3F4"/>
-                </a:solidFill>
-                <a:latin typeface="Consolas"/>
-              </a:rPr>
-              <a:t>  clarity.</a:t>
+              <a:t>per-system scores, per-dimension table, charts, citation metrics, and downloadable JSON.</a:t>
             </a:r>
           </a:p>
         </p:txBody>
@@ -6738,21 +6546,45 @@
                   <a:srgbClr val="FFFFFF"/>
                 </a:solidFill>
               </a:rPr>
-              <a:t>17. Benchmark — The Workflow in the App</a:t>
-            </a:r>
-          </a:p>
-        </p:txBody>
-      </p:sp>
-      <p:sp>
-        <p:nvSpPr>
-          <p:cNvPr id="4" name="TextBox 3"/>
+              <a:t>17. Results — Accuracy by Language</a:t>
+            </a:r>
+          </a:p>
+        </p:txBody>
+      </p:sp>
+      <p:pic>
+        <p:nvPicPr>
+          <p:cNvPr id="4" name="Picture 3" descr="fig_languages.png"/>
+          <p:cNvPicPr>
+            <a:picLocks noChangeAspect="1"/>
+          </p:cNvPicPr>
+          <p:nvPr/>
+        </p:nvPicPr>
+        <p:blipFill>
+          <a:blip r:embed="rId2"/>
+          <a:stretch>
+            <a:fillRect/>
+          </a:stretch>
+        </p:blipFill>
+        <p:spPr>
+          <a:xfrm>
+            <a:off x="548640" y="1280160"/>
+            <a:ext cx="7040209" cy="4297680"/>
+          </a:xfrm>
+          <a:prstGeom prst="rect">
+            <a:avLst/>
+          </a:prstGeom>
+        </p:spPr>
+      </p:pic>
+      <p:sp>
+        <p:nvSpPr>
+          <p:cNvPr id="5" name="TextBox 4"/>
           <p:cNvSpPr txBox="1"/>
           <p:nvPr/>
         </p:nvSpPr>
         <p:spPr>
           <a:xfrm>
-            <a:off x="640080" y="1188720"/>
-            <a:ext cx="10911535" cy="5349240"/>
+            <a:off x="6858000" y="1645920"/>
+            <a:ext cx="4846320" cy="4297680"/>
           </a:xfrm>
           <a:prstGeom prst="rect">
             <a:avLst/>
@@ -6767,116 +6599,70 @@
           <a:p>
             <a:pPr>
               <a:spcAft>
-                <a:spcPts val="900"/>
-              </a:spcAft>
-            </a:pPr>
-            <a:r>
-              <a:rPr sz="1650" b="1" i="0">
+                <a:spcPts val="1300"/>
+              </a:spcAft>
+            </a:pPr>
+            <a:r>
+              <a:rPr sz="1700" b="1" i="0">
                 <a:solidFill>
                   <a:srgbClr val="1E3A5F"/>
                 </a:solidFill>
               </a:rPr>
-              <a:t>• 1 · Generate: </a:t>
-            </a:r>
-            <a:r>
-              <a:rPr sz="1650" b="0" i="0">
+              <a:t>• Arabic (primary legal language): </a:t>
+            </a:r>
+            <a:r>
+              <a:rPr sz="1700" b="0" i="0">
                 <a:solidFill>
                   <a:srgbClr val="444444"/>
                 </a:solidFill>
               </a:rPr>
-              <a:t>set the number of questions; the generator produces grounded questions, shown 10 per page.</a:t>
-            </a:r>
-          </a:p>
-          <a:p>
-            <a:pPr>
-              <a:spcAft>
-                <a:spcPts val="900"/>
-              </a:spcAft>
-            </a:pPr>
-            <a:r>
-              <a:rPr sz="1650" b="1" i="0">
+              <a:t>72% of correct articles in the top 5, 81% in the top 10.</a:t>
+            </a:r>
+          </a:p>
+          <a:p>
+            <a:pPr>
+              <a:spcAft>
+                <a:spcPts val="1300"/>
+              </a:spcAft>
+            </a:pPr>
+            <a:r>
+              <a:rPr sz="1700" b="1" i="0">
                 <a:solidFill>
                   <a:srgbClr val="1E3A5F"/>
                 </a:solidFill>
               </a:rPr>
-              <a:t>• 2 · Reference: </a:t>
-            </a:r>
-            <a:r>
-              <a:rPr sz="1650" b="0" i="0">
+              <a:t>• English / French: </a:t>
+            </a:r>
+            <a:r>
+              <a:rPr sz="1700" b="0" i="0">
                 <a:solidFill>
                   <a:srgbClr val="444444"/>
                 </a:solidFill>
               </a:rPr>
-              <a:t>review them, then type the source-of-truth answer in the editable table (required).</a:t>
-            </a:r>
-          </a:p>
-          <a:p>
-            <a:pPr>
-              <a:spcAft>
-                <a:spcPts val="900"/>
-              </a:spcAft>
-            </a:pPr>
-            <a:r>
-              <a:rPr sz="1650" b="1" i="0">
+              <a:t>lower — the corpus is Arabic-primary; closing this is the main next step.</a:t>
+            </a:r>
+          </a:p>
+          <a:p>
+            <a:pPr>
+              <a:spcAft>
+                <a:spcPts val="800"/>
+              </a:spcAft>
+            </a:pPr>
+            <a:r>
+              <a:rPr sz="1500" b="1" i="0">
                 <a:solidFill>
                   <a:srgbClr val="1E3A5F"/>
                 </a:solidFill>
               </a:rPr>
-              <a:t>• 3 · Select: </a:t>
-            </a:r>
-            <a:r>
-              <a:rPr sz="1650" b="0" i="0">
+              <a:t>• Note: </a:t>
+            </a:r>
+            <a:r>
+              <a:rPr sz="1500" b="0" i="0">
                 <a:solidFill>
                   <a:srgbClr val="444444"/>
                 </a:solidFill>
               </a:rPr>
-              <a:t>choose systems — Multi-Agent vs Single-Agent vs No-RAG.</a:t>
-            </a:r>
-          </a:p>
-          <a:p>
-            <a:pPr>
-              <a:spcAft>
-                <a:spcPts val="900"/>
-              </a:spcAft>
-            </a:pPr>
-            <a:r>
-              <a:rPr sz="1650" b="1" i="0">
-                <a:solidFill>
-                  <a:srgbClr val="1E3A5F"/>
-                </a:solidFill>
-              </a:rPr>
-              <a:t>• 4 · Run: </a:t>
-            </a:r>
-            <a:r>
-              <a:rPr sz="1650" b="0" i="0">
-                <a:solidFill>
-                  <a:srgbClr val="444444"/>
-                </a:solidFill>
-              </a:rPr>
-              <a:t>each system answers; the judge scores every answer against the reference.</a:t>
-            </a:r>
-          </a:p>
-          <a:p>
-            <a:pPr>
-              <a:spcAft>
-                <a:spcPts val="900"/>
-              </a:spcAft>
-            </a:pPr>
-            <a:r>
-              <a:rPr sz="1650" b="1" i="0">
-                <a:solidFill>
-                  <a:srgbClr val="1E3A5F"/>
-                </a:solidFill>
-              </a:rPr>
-              <a:t>• 5 · Results: </a:t>
-            </a:r>
-            <a:r>
-              <a:rPr sz="1650" b="0" i="0">
-                <a:solidFill>
-                  <a:srgbClr val="444444"/>
-                </a:solidFill>
-              </a:rPr>
-              <a:t>per-system scores, per-dimension table, charts, citation metrics, and downloadable JSON.</a:t>
+              <a:t>the article-number metric fairly credits cross-lingual matches.</a:t>
             </a:r>
           </a:p>
         </p:txBody>
@@ -6971,14 +6757,14 @@
                   <a:srgbClr val="FFFFFF"/>
                 </a:solidFill>
               </a:rPr>
-              <a:t>18. Results — Accuracy by Language</a:t>
+              <a:t>18. Results — Search Method &amp; Answer Quality</a:t>
             </a:r>
           </a:p>
         </p:txBody>
       </p:sp>
       <p:pic>
         <p:nvPicPr>
-          <p:cNvPr id="4" name="Picture 3" descr="fig_languages.png"/>
+          <p:cNvPr id="4" name="Picture 3" descr="fig_methods.png"/>
           <p:cNvPicPr>
             <a:picLocks noChangeAspect="1"/>
           </p:cNvPicPr>
@@ -6993,7 +6779,7 @@
         <p:spPr>
           <a:xfrm>
             <a:off x="548640" y="1280160"/>
-            <a:ext cx="7040209" cy="4297680"/>
+            <a:ext cx="7104787" cy="4206240"/>
           </a:xfrm>
           <a:prstGeom prst="rect">
             <a:avLst/>
@@ -7033,7 +6819,7 @@
                   <a:srgbClr val="1E3A5F"/>
                 </a:solidFill>
               </a:rPr>
-              <a:t>• Arabic (primary legal language): </a:t>
+              <a:t>• Best method: </a:t>
             </a:r>
             <a:r>
               <a:rPr sz="1700" b="0" i="0">
@@ -7041,7 +6827,7 @@
                   <a:srgbClr val="444444"/>
                 </a:solidFill>
               </a:rPr>
-              <a:t>72% of correct articles in the top 5, 81% in the top 10.</a:t>
+              <a:t>hybrid (keyword + meaning) finds the correct law most often — chosen default.</a:t>
             </a:r>
           </a:p>
           <a:p>
@@ -7056,7 +6842,7 @@
                   <a:srgbClr val="1E3A5F"/>
                 </a:solidFill>
               </a:rPr>
-              <a:t>• English / French: </a:t>
+              <a:t>• Rejected by data: </a:t>
             </a:r>
             <a:r>
               <a:rPr sz="1700" b="0" i="0">
@@ -7064,30 +6850,53 @@
                   <a:srgbClr val="444444"/>
                 </a:solidFill>
               </a:rPr>
-              <a:t>lower — the corpus is Arabic-primary; closing this is the main next step.</a:t>
-            </a:r>
-          </a:p>
-          <a:p>
-            <a:pPr>
-              <a:spcAft>
-                <a:spcPts val="800"/>
-              </a:spcAft>
-            </a:pPr>
-            <a:r>
-              <a:rPr sz="1500" b="1" i="0">
+              <a:t>a popular English re-ranker made results worse and was removed.</a:t>
+            </a:r>
+          </a:p>
+          <a:p>
+            <a:pPr>
+              <a:spcAft>
+                <a:spcPts val="1300"/>
+              </a:spcAft>
+            </a:pPr>
+            <a:r>
+              <a:rPr sz="1700" b="1" i="0">
                 <a:solidFill>
                   <a:srgbClr val="1E3A5F"/>
                 </a:solidFill>
               </a:rPr>
-              <a:t>• Note: </a:t>
-            </a:r>
-            <a:r>
-              <a:rPr sz="1500" b="0" i="0">
+              <a:t>• Answer quality: </a:t>
+            </a:r>
+            <a:r>
+              <a:rPr sz="1700" b="0" i="0">
                 <a:solidFill>
                   <a:srgbClr val="444444"/>
                 </a:solidFill>
               </a:rPr>
-              <a:t>the article-number metric fairly credits cross-lingual matches.</a:t>
+              <a:t>final memoranda rated ~4.6/5 for legal quality by the judge.</a:t>
+            </a:r>
+          </a:p>
+          <a:p>
+            <a:pPr>
+              <a:spcAft>
+                <a:spcPts val="1300"/>
+              </a:spcAft>
+            </a:pPr>
+            <a:r>
+              <a:rPr sz="1700" b="1" i="0">
+                <a:solidFill>
+                  <a:srgbClr val="1E3A5F"/>
+                </a:solidFill>
+              </a:rPr>
+              <a:t>• Practical: </a:t>
+            </a:r>
+            <a:r>
+              <a:rPr sz="1700" b="0" i="0">
+                <a:solidFill>
+                  <a:srgbClr val="444444"/>
+                </a:solidFill>
+              </a:rPr>
+              <a:t>~2–3 minutes, ~$0.12 per full answer.</a:t>
             </a:r>
           </a:p>
         </p:txBody>
@@ -7182,45 +6991,21 @@
                   <a:srgbClr val="FFFFFF"/>
                 </a:solidFill>
               </a:rPr>
-              <a:t>19. Results — Search Method &amp; Answer Quality</a:t>
-            </a:r>
-          </a:p>
-        </p:txBody>
-      </p:sp>
-      <p:pic>
-        <p:nvPicPr>
-          <p:cNvPr id="4" name="Picture 3" descr="fig_methods.png"/>
-          <p:cNvPicPr>
-            <a:picLocks noChangeAspect="1"/>
-          </p:cNvPicPr>
-          <p:nvPr/>
-        </p:nvPicPr>
-        <p:blipFill>
-          <a:blip r:embed="rId2"/>
-          <a:stretch>
-            <a:fillRect/>
-          </a:stretch>
-        </p:blipFill>
-        <p:spPr>
-          <a:xfrm>
-            <a:off x="548640" y="1280160"/>
-            <a:ext cx="7104787" cy="4206240"/>
-          </a:xfrm>
-          <a:prstGeom prst="rect">
-            <a:avLst/>
-          </a:prstGeom>
-        </p:spPr>
-      </p:pic>
-      <p:sp>
-        <p:nvSpPr>
-          <p:cNvPr id="5" name="TextBox 4"/>
+              <a:t>19. Key Findings</a:t>
+            </a:r>
+          </a:p>
+        </p:txBody>
+      </p:sp>
+      <p:sp>
+        <p:nvSpPr>
+          <p:cNvPr id="4" name="TextBox 3"/>
           <p:cNvSpPr txBox="1"/>
           <p:nvPr/>
         </p:nvSpPr>
         <p:spPr>
           <a:xfrm>
-            <a:off x="6858000" y="1645920"/>
-            <a:ext cx="4846320" cy="4297680"/>
+            <a:off x="640080" y="1188720"/>
+            <a:ext cx="10911535" cy="5349240"/>
           </a:xfrm>
           <a:prstGeom prst="rect">
             <a:avLst/>
@@ -7235,7 +7020,7 @@
           <a:p>
             <a:pPr>
               <a:spcAft>
-                <a:spcPts val="1300"/>
+                <a:spcPts val="800"/>
               </a:spcAft>
             </a:pPr>
             <a:r>
@@ -7244,7 +7029,7 @@
                   <a:srgbClr val="1E3A5F"/>
                 </a:solidFill>
               </a:rPr>
-              <a:t>• Best method: </a:t>
+              <a:t>• Multi-agent works: </a:t>
             </a:r>
             <a:r>
               <a:rPr sz="1700" b="0" i="0">
@@ -7252,13 +7037,13 @@
                   <a:srgbClr val="444444"/>
                 </a:solidFill>
               </a:rPr>
-              <a:t>hybrid (keyword + meaning) finds the correct law most often — chosen default.</a:t>
-            </a:r>
-          </a:p>
-          <a:p>
-            <a:pPr>
-              <a:spcAft>
-                <a:spcPts val="1300"/>
+              <a:t>specialised agents produce grounded, well-structured answers (~4.6/5).</a:t>
+            </a:r>
+          </a:p>
+          <a:p>
+            <a:pPr>
+              <a:spcAft>
+                <a:spcPts val="800"/>
               </a:spcAft>
             </a:pPr>
             <a:r>
@@ -7267,7 +7052,7 @@
                   <a:srgbClr val="1E3A5F"/>
                 </a:solidFill>
               </a:rPr>
-              <a:t>• Rejected by data: </a:t>
+              <a:t>• Evidence-based engineering: </a:t>
             </a:r>
             <a:r>
               <a:rPr sz="1700" b="0" i="0">
@@ -7275,13 +7060,13 @@
                   <a:srgbClr val="444444"/>
                 </a:solidFill>
               </a:rPr>
-              <a:t>a popular English re-ranker made results worse and was removed.</a:t>
-            </a:r>
-          </a:p>
-          <a:p>
-            <a:pPr>
-              <a:spcAft>
-                <a:spcPts val="1300"/>
+              <a:t>hybrid &gt; semantic; the re-ranker hurts; the embedding is validated — all decided by the benchmark.</a:t>
+            </a:r>
+          </a:p>
+          <a:p>
+            <a:pPr>
+              <a:spcAft>
+                <a:spcPts val="800"/>
               </a:spcAft>
             </a:pPr>
             <a:r>
@@ -7290,7 +7075,7 @@
                   <a:srgbClr val="1E3A5F"/>
                 </a:solidFill>
               </a:rPr>
-              <a:t>• Answer quality: </a:t>
+              <a:t>• Bottleneck identified: </a:t>
             </a:r>
             <a:r>
               <a:rPr sz="1700" b="0" i="0">
@@ -7298,13 +7083,13 @@
                   <a:srgbClr val="444444"/>
                 </a:solidFill>
               </a:rPr>
-              <a:t>final memoranda rated ~4.6/5 for legal quality by the judge.</a:t>
-            </a:r>
-          </a:p>
-          <a:p>
-            <a:pPr>
-              <a:spcAft>
-                <a:spcPts val="1300"/>
+              <a:t>answer quality is bounded by retrieval recall — if the article isn't found, it can't be cited.</a:t>
+            </a:r>
+          </a:p>
+          <a:p>
+            <a:pPr>
+              <a:spcAft>
+                <a:spcPts val="800"/>
               </a:spcAft>
             </a:pPr>
             <a:r>
@@ -7313,7 +7098,7 @@
                   <a:srgbClr val="1E3A5F"/>
                 </a:solidFill>
               </a:rPr>
-              <a:t>• Practical: </a:t>
+              <a:t>• Precision fix, measured: </a:t>
             </a:r>
             <a:r>
               <a:rPr sz="1700" b="0" i="0">
@@ -7321,7 +7106,7 @@
                   <a:srgbClr val="444444"/>
                 </a:solidFill>
               </a:rPr>
-              <a:t>~2–3 minutes, ~$0.12 per full answer.</a:t>
+              <a:t>tightening citations raised citation-F1 ~3× (0.04 → 0.13) on the same questions.</a:t>
             </a:r>
           </a:p>
         </p:txBody>
@@ -7416,7 +7201,7 @@
                   <a:srgbClr val="FFFFFF"/>
                 </a:solidFill>
               </a:rPr>
-              <a:t>20. Key Findings</a:t>
+              <a:t>20. Engineering &amp; Reproducibility</a:t>
             </a:r>
           </a:p>
         </p:txBody>
@@ -7445,93 +7230,139 @@
           <a:p>
             <a:pPr>
               <a:spcAft>
-                <a:spcPts val="800"/>
-              </a:spcAft>
-            </a:pPr>
-            <a:r>
-              <a:rPr sz="1700" b="1" i="0">
+                <a:spcPts val="900"/>
+              </a:spcAft>
+            </a:pPr>
+            <a:r>
+              <a:rPr sz="1650" b="1" i="0">
                 <a:solidFill>
                   <a:srgbClr val="1E3A5F"/>
                 </a:solidFill>
               </a:rPr>
-              <a:t>• Multi-agent works: </a:t>
-            </a:r>
-            <a:r>
-              <a:rPr sz="1700" b="0" i="0">
+              <a:t>• Standardised model: </a:t>
+            </a:r>
+            <a:r>
+              <a:rPr sz="1650" b="0" i="0">
                 <a:solidFill>
                   <a:srgbClr val="444444"/>
                 </a:solidFill>
               </a:rPr>
-              <a:t>specialised agents produce grounded, well-structured answers (~4.6/5).</a:t>
-            </a:r>
-          </a:p>
-          <a:p>
-            <a:pPr>
-              <a:spcAft>
-                <a:spcPts val="800"/>
-              </a:spcAft>
-            </a:pPr>
-            <a:r>
-              <a:rPr sz="1700" b="1" i="0">
+              <a:t>Claude Sonnet 4.5 (selectable: 4.6 / Opus / Haiku).</a:t>
+            </a:r>
+          </a:p>
+          <a:p>
+            <a:pPr>
+              <a:spcAft>
+                <a:spcPts val="900"/>
+              </a:spcAft>
+            </a:pPr>
+            <a:r>
+              <a:rPr sz="1650" b="1" i="0">
                 <a:solidFill>
                   <a:srgbClr val="1E3A5F"/>
                 </a:solidFill>
               </a:rPr>
-              <a:t>• Evidence-based engineering: </a:t>
-            </a:r>
-            <a:r>
-              <a:rPr sz="1700" b="0" i="0">
+              <a:t>• Headless pipeline: </a:t>
+            </a:r>
+            <a:r>
+              <a:rPr sz="1650" b="0" i="0">
                 <a:solidFill>
                   <a:srgbClr val="444444"/>
                 </a:solidFill>
               </a:rPr>
-              <a:t>hybrid &gt; semantic; the re-ranker hurts; the embedding is validated — all decided by the benchmark.</a:t>
-            </a:r>
-          </a:p>
-          <a:p>
-            <a:pPr>
-              <a:spcAft>
-                <a:spcPts val="800"/>
-              </a:spcAft>
-            </a:pPr>
-            <a:r>
-              <a:rPr sz="1700" b="1" i="0">
+              <a:t>the full system runs without the UI for batch evaluation.</a:t>
+            </a:r>
+          </a:p>
+          <a:p>
+            <a:pPr>
+              <a:spcAft>
+                <a:spcPts val="900"/>
+              </a:spcAft>
+            </a:pPr>
+            <a:r>
+              <a:rPr sz="1650" b="1" i="0">
                 <a:solidFill>
                   <a:srgbClr val="1E3A5F"/>
                 </a:solidFill>
               </a:rPr>
-              <a:t>• Bottleneck identified: </a:t>
-            </a:r>
-            <a:r>
-              <a:rPr sz="1700" b="0" i="0">
+              <a:t>• Tests + CI: </a:t>
+            </a:r>
+            <a:r>
+              <a:rPr sz="1650" b="0" i="0">
                 <a:solidFill>
                   <a:srgbClr val="444444"/>
                 </a:solidFill>
               </a:rPr>
-              <a:t>answer quality is bounded by retrieval recall — if the article isn't found, it can't be cited.</a:t>
-            </a:r>
-          </a:p>
-          <a:p>
-            <a:pPr>
-              <a:spcAft>
-                <a:spcPts val="800"/>
-              </a:spcAft>
-            </a:pPr>
-            <a:r>
-              <a:rPr sz="1700" b="1" i="0">
+              <a:t>unit tests and GitHub Actions run automatically on every change.</a:t>
+            </a:r>
+          </a:p>
+          <a:p>
+            <a:pPr>
+              <a:spcAft>
+                <a:spcPts val="900"/>
+              </a:spcAft>
+            </a:pPr>
+            <a:r>
+              <a:rPr sz="1650" b="1" i="0">
                 <a:solidFill>
                   <a:srgbClr val="1E3A5F"/>
                 </a:solidFill>
               </a:rPr>
-              <a:t>• Precision fix, measured: </a:t>
-            </a:r>
-            <a:r>
-              <a:rPr sz="1700" b="0" i="0">
+              <a:t>• Telemetry: </a:t>
+            </a:r>
+            <a:r>
+              <a:rPr sz="1650" b="0" i="0">
                 <a:solidFill>
                   <a:srgbClr val="444444"/>
                 </a:solidFill>
               </a:rPr>
-              <a:t>tightening citations raised citation-F1 ~3× (0.04 → 0.13) on the same questions.</a:t>
+              <a:t>tokens, cost, and latency tracked per agent.</a:t>
+            </a:r>
+          </a:p>
+          <a:p>
+            <a:pPr>
+              <a:spcAft>
+                <a:spcPts val="900"/>
+              </a:spcAft>
+            </a:pPr>
+            <a:r>
+              <a:rPr sz="1650" b="1" i="0">
+                <a:solidFill>
+                  <a:srgbClr val="1E3A5F"/>
+                </a:solidFill>
+              </a:rPr>
+              <a:t>• Reproducible: </a:t>
+            </a:r>
+            <a:r>
+              <a:rPr sz="1650" b="0" i="0">
+                <a:solidFill>
+                  <a:srgbClr val="444444"/>
+                </a:solidFill>
+              </a:rPr>
+              <a:t>one command rebuilds the index; the benchmark is regenerable.</a:t>
+            </a:r>
+          </a:p>
+          <a:p>
+            <a:pPr>
+              <a:spcAft>
+                <a:spcPts val="900"/>
+              </a:spcAft>
+            </a:pPr>
+            <a:r>
+              <a:rPr sz="1650" b="1" i="0">
+                <a:solidFill>
+                  <a:srgbClr val="1E3A5F"/>
+                </a:solidFill>
+              </a:rPr>
+              <a:t>• Version-controlled: </a:t>
+            </a:r>
+            <a:r>
+              <a:rPr sz="1650" b="0" i="0">
+                <a:solidFill>
+                  <a:srgbClr val="444444"/>
+                </a:solidFill>
+              </a:rPr>
+              <a:t>all work committed and pushed to GitHub.</a:t>
             </a:r>
           </a:p>
         </p:txBody>
@@ -7626,7 +7457,7 @@
                   <a:srgbClr val="FFFFFF"/>
                 </a:solidFill>
               </a:rPr>
-              <a:t>21. Engineering &amp; Reproducibility</a:t>
+              <a:t>21. Limitations &amp; Future Work</a:t>
             </a:r>
           </a:p>
         </p:txBody>
@@ -7655,139 +7486,116 @@
           <a:p>
             <a:pPr>
               <a:spcAft>
-                <a:spcPts val="900"/>
-              </a:spcAft>
-            </a:pPr>
-            <a:r>
-              <a:rPr sz="1650" b="1" i="0">
+                <a:spcPts val="800"/>
+              </a:spcAft>
+            </a:pPr>
+            <a:r>
+              <a:rPr sz="1700" b="1" i="0">
                 <a:solidFill>
                   <a:srgbClr val="1E3A5F"/>
                 </a:solidFill>
               </a:rPr>
-              <a:t>• Standardised model: </a:t>
-            </a:r>
-            <a:r>
-              <a:rPr sz="1650" b="0" i="0">
+              <a:t>• Limitation: </a:t>
+            </a:r>
+            <a:r>
+              <a:rPr sz="1700" b="0" i="0">
                 <a:solidFill>
                   <a:srgbClr val="444444"/>
                 </a:solidFill>
               </a:rPr>
-              <a:t>Claude Sonnet 4.5 (selectable: 4.6 / Opus / Haiku).</a:t>
-            </a:r>
-          </a:p>
-          <a:p>
-            <a:pPr>
-              <a:spcAft>
-                <a:spcPts val="900"/>
-              </a:spcAft>
-            </a:pPr>
-            <a:r>
-              <a:rPr sz="1650" b="1" i="0">
+              <a:t>English/French retrieval lags Arabic (~40% vs 72%).</a:t>
+            </a:r>
+          </a:p>
+          <a:p>
+            <a:pPr>
+              <a:spcAft>
+                <a:spcPts val="800"/>
+              </a:spcAft>
+            </a:pPr>
+            <a:r>
+              <a:rPr sz="1700" b="1" i="0">
                 <a:solidFill>
                   <a:srgbClr val="1E3A5F"/>
                 </a:solidFill>
               </a:rPr>
-              <a:t>• Headless pipeline: </a:t>
-            </a:r>
-            <a:r>
-              <a:rPr sz="1650" b="0" i="0">
+              <a:t>• Scope: </a:t>
+            </a:r>
+            <a:r>
+              <a:rPr sz="1700" b="0" i="0">
                 <a:solidFill>
                   <a:srgbClr val="444444"/>
                 </a:solidFill>
               </a:rPr>
-              <a:t>the full system runs without the UI for batch evaluation.</a:t>
-            </a:r>
-          </a:p>
-          <a:p>
-            <a:pPr>
-              <a:spcAft>
-                <a:spcPts val="900"/>
-              </a:spcAft>
-            </a:pPr>
-            <a:r>
-              <a:rPr sz="1650" b="1" i="0">
+              <a:t>corpus is criminal (Penal) law only; single-article gold is strict for multi-article questions.</a:t>
+            </a:r>
+          </a:p>
+          <a:p>
+            <a:pPr>
+              <a:spcAft>
+                <a:spcPts val="800"/>
+              </a:spcAft>
+            </a:pPr>
+            <a:r>
+              <a:rPr sz="1700" b="1" i="0">
                 <a:solidFill>
                   <a:srgbClr val="1E3A5F"/>
                 </a:solidFill>
               </a:rPr>
-              <a:t>• Tests + CI: </a:t>
-            </a:r>
-            <a:r>
-              <a:rPr sz="1650" b="0" i="0">
+              <a:t>• Next — retrieval: </a:t>
+            </a:r>
+            <a:r>
+              <a:rPr sz="1700" b="0" i="0">
                 <a:solidFill>
                   <a:srgbClr val="444444"/>
                 </a:solidFill>
               </a:rPr>
-              <a:t>unit tests and GitHub Actions run automatically on every change.</a:t>
-            </a:r>
-          </a:p>
-          <a:p>
-            <a:pPr>
-              <a:spcAft>
-                <a:spcPts val="900"/>
-              </a:spcAft>
-            </a:pPr>
-            <a:r>
-              <a:rPr sz="1650" b="1" i="0">
+              <a:t>evaluate the built-in cross-lingual translation; test stronger multilingual embeddings.</a:t>
+            </a:r>
+          </a:p>
+          <a:p>
+            <a:pPr>
+              <a:spcAft>
+                <a:spcPts val="800"/>
+              </a:spcAft>
+            </a:pPr>
+            <a:r>
+              <a:rPr sz="1700" b="1" i="0">
                 <a:solidFill>
                   <a:srgbClr val="1E3A5F"/>
                 </a:solidFill>
               </a:rPr>
-              <a:t>• Telemetry: </a:t>
-            </a:r>
-            <a:r>
-              <a:rPr sz="1650" b="0" i="0">
+              <a:t>• Next — corpus &amp; rigor: </a:t>
+            </a:r>
+            <a:r>
+              <a:rPr sz="1700" b="0" i="0">
                 <a:solidFill>
                   <a:srgbClr val="444444"/>
                 </a:solidFill>
               </a:rPr>
-              <a:t>tokens, cost, and latency tracked per agent.</a:t>
-            </a:r>
-          </a:p>
-          <a:p>
-            <a:pPr>
-              <a:spcAft>
-                <a:spcPts val="900"/>
-              </a:spcAft>
-            </a:pPr>
-            <a:r>
-              <a:rPr sz="1650" b="1" i="0">
+              <a:t>add contract law + French texts (pipeline supports it); collect expert reference answers at scale.</a:t>
+            </a:r>
+          </a:p>
+          <a:p>
+            <a:pPr>
+              <a:spcAft>
+                <a:spcPts val="800"/>
+              </a:spcAft>
+            </a:pPr>
+            <a:r>
+              <a:rPr sz="1700" b="1" i="0">
                 <a:solidFill>
                   <a:srgbClr val="1E3A5F"/>
                 </a:solidFill>
               </a:rPr>
-              <a:t>• Reproducible: </a:t>
-            </a:r>
-            <a:r>
-              <a:rPr sz="1650" b="0" i="0">
+              <a:t>• Next — agents &amp; eval: </a:t>
+            </a:r>
+            <a:r>
+              <a:rPr sz="1700" b="0" i="0">
                 <a:solidFill>
                   <a:srgbClr val="444444"/>
                 </a:solidFill>
               </a:rPr>
-              <a:t>one command rebuilds the index; the benchmark is regenerable.</a:t>
-            </a:r>
-          </a:p>
-          <a:p>
-            <a:pPr>
-              <a:spcAft>
-                <a:spcPts val="900"/>
-              </a:spcAft>
-            </a:pPr>
-            <a:r>
-              <a:rPr sz="1650" b="1" i="0">
-                <a:solidFill>
-                  <a:srgbClr val="1E3A5F"/>
-                </a:solidFill>
-              </a:rPr>
-              <a:t>• Version-controlled: </a:t>
-            </a:r>
-            <a:r>
-              <a:rPr sz="1650" b="0" i="0">
-                <a:solidFill>
-                  <a:srgbClr val="444444"/>
-                </a:solidFill>
-              </a:rPr>
-              <a:t>all work committed and pushed to GitHub.</a:t>
+              <a:t>structured reasoning, a verifier agent, and a full statistical comparison run.</a:t>
             </a:r>
           </a:p>
         </p:txBody>
@@ -7819,7 +7627,7 @@
         <p:spPr>
           <a:xfrm>
             <a:off x="0" y="0"/>
-            <a:ext cx="12191695" cy="960120"/>
+            <a:ext cx="12191695" cy="6858000"/>
           </a:xfrm>
           <a:prstGeom prst="rect">
             <a:avLst/>
@@ -7856,239 +7664,6 @@
       </p:sp>
       <p:sp>
         <p:nvSpPr>
-          <p:cNvPr id="3" name="TextBox 2"/>
-          <p:cNvSpPr txBox="1"/>
-          <p:nvPr/>
-        </p:nvSpPr>
-        <p:spPr>
-          <a:xfrm>
-            <a:off x="457200" y="73152"/>
-            <a:ext cx="11277295" cy="822960"/>
-          </a:xfrm>
-          <a:prstGeom prst="rect">
-            <a:avLst/>
-          </a:prstGeom>
-          <a:noFill/>
-        </p:spPr>
-        <p:txBody>
-          <a:bodyPr wrap="square">
-            <a:spAutoFit/>
-          </a:bodyPr>
-          <a:lstStyle/>
-          <a:p>
-            <a:r>
-              <a:rPr sz="2700" b="1" i="0">
-                <a:solidFill>
-                  <a:srgbClr val="FFFFFF"/>
-                </a:solidFill>
-              </a:rPr>
-              <a:t>22. Limitations &amp; Future Work</a:t>
-            </a:r>
-          </a:p>
-        </p:txBody>
-      </p:sp>
-      <p:sp>
-        <p:nvSpPr>
-          <p:cNvPr id="4" name="TextBox 3"/>
-          <p:cNvSpPr txBox="1"/>
-          <p:nvPr/>
-        </p:nvSpPr>
-        <p:spPr>
-          <a:xfrm>
-            <a:off x="640080" y="1188720"/>
-            <a:ext cx="10911535" cy="5349240"/>
-          </a:xfrm>
-          <a:prstGeom prst="rect">
-            <a:avLst/>
-          </a:prstGeom>
-          <a:noFill/>
-        </p:spPr>
-        <p:txBody>
-          <a:bodyPr wrap="square">
-            <a:spAutoFit/>
-          </a:bodyPr>
-          <a:lstStyle/>
-          <a:p>
-            <a:pPr>
-              <a:spcAft>
-                <a:spcPts val="800"/>
-              </a:spcAft>
-            </a:pPr>
-            <a:r>
-              <a:rPr sz="1700" b="1" i="0">
-                <a:solidFill>
-                  <a:srgbClr val="1E3A5F"/>
-                </a:solidFill>
-              </a:rPr>
-              <a:t>• Limitation: </a:t>
-            </a:r>
-            <a:r>
-              <a:rPr sz="1700" b="0" i="0">
-                <a:solidFill>
-                  <a:srgbClr val="444444"/>
-                </a:solidFill>
-              </a:rPr>
-              <a:t>English/French retrieval lags Arabic (~40% vs 72%).</a:t>
-            </a:r>
-          </a:p>
-          <a:p>
-            <a:pPr>
-              <a:spcAft>
-                <a:spcPts val="800"/>
-              </a:spcAft>
-            </a:pPr>
-            <a:r>
-              <a:rPr sz="1700" b="1" i="0">
-                <a:solidFill>
-                  <a:srgbClr val="1E3A5F"/>
-                </a:solidFill>
-              </a:rPr>
-              <a:t>• Scope: </a:t>
-            </a:r>
-            <a:r>
-              <a:rPr sz="1700" b="0" i="0">
-                <a:solidFill>
-                  <a:srgbClr val="444444"/>
-                </a:solidFill>
-              </a:rPr>
-              <a:t>corpus is criminal (Penal) law only; single-article gold is strict for multi-article questions.</a:t>
-            </a:r>
-          </a:p>
-          <a:p>
-            <a:pPr>
-              <a:spcAft>
-                <a:spcPts val="800"/>
-              </a:spcAft>
-            </a:pPr>
-            <a:r>
-              <a:rPr sz="1700" b="1" i="0">
-                <a:solidFill>
-                  <a:srgbClr val="1E3A5F"/>
-                </a:solidFill>
-              </a:rPr>
-              <a:t>• Next — retrieval: </a:t>
-            </a:r>
-            <a:r>
-              <a:rPr sz="1700" b="0" i="0">
-                <a:solidFill>
-                  <a:srgbClr val="444444"/>
-                </a:solidFill>
-              </a:rPr>
-              <a:t>evaluate the built-in cross-lingual translation; test stronger multilingual embeddings.</a:t>
-            </a:r>
-          </a:p>
-          <a:p>
-            <a:pPr>
-              <a:spcAft>
-                <a:spcPts val="800"/>
-              </a:spcAft>
-            </a:pPr>
-            <a:r>
-              <a:rPr sz="1700" b="1" i="0">
-                <a:solidFill>
-                  <a:srgbClr val="1E3A5F"/>
-                </a:solidFill>
-              </a:rPr>
-              <a:t>• Next — corpus &amp; rigor: </a:t>
-            </a:r>
-            <a:r>
-              <a:rPr sz="1700" b="0" i="0">
-                <a:solidFill>
-                  <a:srgbClr val="444444"/>
-                </a:solidFill>
-              </a:rPr>
-              <a:t>add contract law + French texts (pipeline supports it); collect expert reference answers at scale.</a:t>
-            </a:r>
-          </a:p>
-          <a:p>
-            <a:pPr>
-              <a:spcAft>
-                <a:spcPts val="800"/>
-              </a:spcAft>
-            </a:pPr>
-            <a:r>
-              <a:rPr sz="1700" b="1" i="0">
-                <a:solidFill>
-                  <a:srgbClr val="1E3A5F"/>
-                </a:solidFill>
-              </a:rPr>
-              <a:t>• Next — agents &amp; eval: </a:t>
-            </a:r>
-            <a:r>
-              <a:rPr sz="1700" b="0" i="0">
-                <a:solidFill>
-                  <a:srgbClr val="444444"/>
-                </a:solidFill>
-              </a:rPr>
-              <a:t>structured reasoning, a verifier agent, and a full statistical comparison run.</a:t>
-            </a:r>
-          </a:p>
-        </p:txBody>
-      </p:sp>
-    </p:spTree>
-  </p:cSld>
-  <p:clrMapOvr>
-    <a:masterClrMapping/>
-  </p:clrMapOvr>
-</p:sld>
-</file>
-
-<file path=ppt/slides/slide26.xml><?xml version="1.0" encoding="utf-8"?>
-<p:sld xmlns:a="http://schemas.openxmlformats.org/drawingml/2006/main" xmlns:p="http://schemas.openxmlformats.org/presentationml/2006/main" xmlns:r="http://schemas.openxmlformats.org/officeDocument/2006/relationships">
-  <p:cSld>
-    <p:spTree>
-      <p:nvGrpSpPr>
-        <p:cNvPr id="1" name=""/>
-        <p:cNvGrpSpPr/>
-        <p:nvPr/>
-      </p:nvGrpSpPr>
-      <p:grpSpPr/>
-      <p:sp>
-        <p:nvSpPr>
-          <p:cNvPr id="2" name="Rectangle 1"/>
-          <p:cNvSpPr/>
-          <p:nvPr/>
-        </p:nvSpPr>
-        <p:spPr>
-          <a:xfrm>
-            <a:off x="0" y="0"/>
-            <a:ext cx="12191695" cy="6858000"/>
-          </a:xfrm>
-          <a:prstGeom prst="rect">
-            <a:avLst/>
-          </a:prstGeom>
-          <a:solidFill>
-            <a:srgbClr val="1E3A5F"/>
-          </a:solidFill>
-          <a:ln>
-            <a:noFill/>
-          </a:ln>
-          <a:effectLst/>
-        </p:spPr>
-        <p:style>
-          <a:lnRef idx="1">
-            <a:schemeClr val="accent1"/>
-          </a:lnRef>
-          <a:fillRef idx="3">
-            <a:schemeClr val="accent1"/>
-          </a:fillRef>
-          <a:effectRef idx="2">
-            <a:schemeClr val="accent1"/>
-          </a:effectRef>
-          <a:fontRef idx="minor">
-            <a:schemeClr val="lt1"/>
-          </a:fontRef>
-        </p:style>
-        <p:txBody>
-          <a:bodyPr rtlCol="0" anchor="ctr"/>
-          <a:lstStyle/>
-          <a:p>
-            <a:pPr algn="ctr"/>
-          </a:p>
-        </p:txBody>
-      </p:sp>
-      <p:sp>
-        <p:nvSpPr>
           <p:cNvPr id="3" name="Rectangle 2"/>
           <p:cNvSpPr/>
           <p:nvPr/>
@@ -8159,7 +7734,7 @@
                   <a:srgbClr val="FFFFFF"/>
                 </a:solidFill>
               </a:rPr>
-              <a:t>23. Conclusion &amp; Contributions</a:t>
+              <a:t>22. Conclusion &amp; Contributions</a:t>
             </a:r>
           </a:p>
         </p:txBody>

</xml_diff>